<commit_message>
Update presentation to a clean, presentable light theme
</commit_message>
<xml_diff>
--- a/presentation.pptx
+++ b/presentation.pptx
@@ -3093,7 +3093,7 @@
     <p:bg>
       <p:bgPr>
         <a:solidFill>
-          <a:srgbClr val="0F172A"/>
+          <a:srgbClr val="F8FAFC"/>
         </a:solidFill>
         <a:effectLst/>
       </p:bgPr>
@@ -3130,7 +3130,7 @@
             <a:pPr>
               <a:defRPr sz="2000" b="1">
                 <a:solidFill>
-                  <a:srgbClr val="0EA5E9"/>
+                  <a:srgbClr val="2563EB"/>
                 </a:solidFill>
                 <a:latin typeface="Segoe UI"/>
               </a:defRPr>
@@ -3166,7 +3166,7 @@
             <a:pPr>
               <a:defRPr sz="6400" b="1">
                 <a:solidFill>
-                  <a:srgbClr val="FFFFFF"/>
+                  <a:srgbClr val="0F172A"/>
                 </a:solidFill>
                 <a:latin typeface="Segoe UI"/>
               </a:defRPr>
@@ -3202,7 +3202,7 @@
             <a:pPr>
               <a:defRPr sz="2200">
                 <a:solidFill>
-                  <a:srgbClr val="A855F7"/>
+                  <a:srgbClr val="334155"/>
                 </a:solidFill>
                 <a:latin typeface="Segoe UI"/>
               </a:defRPr>
@@ -3238,7 +3238,7 @@
             <a:pPr>
               <a:defRPr sz="1400">
                 <a:solidFill>
-                  <a:srgbClr val="94A3B8"/>
+                  <a:srgbClr val="64748B"/>
                 </a:solidFill>
                 <a:latin typeface="Segoe UI"/>
               </a:defRPr>
@@ -3267,7 +3267,7 @@
     <p:bg>
       <p:bgPr>
         <a:solidFill>
-          <a:srgbClr val="0F172A"/>
+          <a:srgbClr val="F8FAFC"/>
         </a:solidFill>
         <a:effectLst/>
       </p:bgPr>
@@ -3307,7 +3307,7 @@
               </a:spcAft>
               <a:defRPr sz="1200" b="1">
                 <a:solidFill>
-                  <a:srgbClr val="0EA5E9"/>
+                  <a:srgbClr val="2563EB"/>
                 </a:solidFill>
                 <a:latin typeface="Segoe UI"/>
               </a:defRPr>
@@ -3320,7 +3320,7 @@
             <a:pPr>
               <a:defRPr sz="3600" b="1">
                 <a:solidFill>
-                  <a:srgbClr val="FFFFFF"/>
+                  <a:srgbClr val="0F172A"/>
                 </a:solidFill>
                 <a:latin typeface="Segoe UI"/>
               </a:defRPr>
@@ -3333,7 +3333,7 @@
             <a:pPr>
               <a:defRPr sz="1600">
                 <a:solidFill>
-                  <a:srgbClr val="A855F7"/>
+                  <a:srgbClr val="64748B"/>
                 </a:solidFill>
                 <a:latin typeface="Segoe UI"/>
               </a:defRPr>
@@ -3375,7 +3375,7 @@
               </a:spcAft>
               <a:defRPr sz="1600">
                 <a:solidFill>
-                  <a:srgbClr val="FFFFFF"/>
+                  <a:srgbClr val="334155"/>
                 </a:solidFill>
                 <a:latin typeface="Segoe UI"/>
               </a:defRPr>
@@ -3394,7 +3394,7 @@
               </a:spcAft>
               <a:defRPr sz="1600">
                 <a:solidFill>
-                  <a:srgbClr val="FFFFFF"/>
+                  <a:srgbClr val="334155"/>
                 </a:solidFill>
                 <a:latin typeface="Segoe UI"/>
               </a:defRPr>
@@ -3413,7 +3413,7 @@
               </a:spcAft>
               <a:defRPr sz="1600">
                 <a:solidFill>
-                  <a:srgbClr val="FFFFFF"/>
+                  <a:srgbClr val="334155"/>
                 </a:solidFill>
                 <a:latin typeface="Segoe UI"/>
               </a:defRPr>
@@ -3432,7 +3432,7 @@
               </a:spcAft>
               <a:defRPr sz="1600">
                 <a:solidFill>
-                  <a:srgbClr val="FFFFFF"/>
+                  <a:srgbClr val="334155"/>
                 </a:solidFill>
                 <a:latin typeface="Segoe UI"/>
               </a:defRPr>
@@ -3451,7 +3451,7 @@
               </a:spcAft>
               <a:defRPr sz="1600">
                 <a:solidFill>
-                  <a:srgbClr val="FFFFFF"/>
+                  <a:srgbClr val="334155"/>
                 </a:solidFill>
                 <a:latin typeface="Segoe UI"/>
               </a:defRPr>
@@ -3476,7 +3476,7 @@
     <p:bg>
       <p:bgPr>
         <a:solidFill>
-          <a:srgbClr val="0F172A"/>
+          <a:srgbClr val="F8FAFC"/>
         </a:solidFill>
         <a:effectLst/>
       </p:bgPr>
@@ -3516,7 +3516,7 @@
               </a:spcAft>
               <a:defRPr sz="1200" b="1">
                 <a:solidFill>
-                  <a:srgbClr val="0EA5E9"/>
+                  <a:srgbClr val="2563EB"/>
                 </a:solidFill>
                 <a:latin typeface="Segoe UI"/>
               </a:defRPr>
@@ -3529,7 +3529,7 @@
             <a:pPr>
               <a:defRPr sz="3600" b="1">
                 <a:solidFill>
-                  <a:srgbClr val="FFFFFF"/>
+                  <a:srgbClr val="0F172A"/>
                 </a:solidFill>
                 <a:latin typeface="Segoe UI"/>
               </a:defRPr>
@@ -3542,7 +3542,7 @@
             <a:pPr>
               <a:defRPr sz="1600">
                 <a:solidFill>
-                  <a:srgbClr val="A855F7"/>
+                  <a:srgbClr val="64748B"/>
                 </a:solidFill>
                 <a:latin typeface="Segoe UI"/>
               </a:defRPr>
@@ -3584,7 +3584,7 @@
               </a:spcAft>
               <a:defRPr sz="1600">
                 <a:solidFill>
-                  <a:srgbClr val="FFFFFF"/>
+                  <a:srgbClr val="334155"/>
                 </a:solidFill>
                 <a:latin typeface="Segoe UI"/>
               </a:defRPr>
@@ -3603,7 +3603,7 @@
               </a:spcAft>
               <a:defRPr sz="1600">
                 <a:solidFill>
-                  <a:srgbClr val="FFFFFF"/>
+                  <a:srgbClr val="334155"/>
                 </a:solidFill>
                 <a:latin typeface="Segoe UI"/>
               </a:defRPr>
@@ -3622,7 +3622,7 @@
               </a:spcAft>
               <a:defRPr sz="1600">
                 <a:solidFill>
-                  <a:srgbClr val="FFFFFF"/>
+                  <a:srgbClr val="334155"/>
                 </a:solidFill>
                 <a:latin typeface="Segoe UI"/>
               </a:defRPr>
@@ -3641,7 +3641,7 @@
               </a:spcAft>
               <a:defRPr sz="1600">
                 <a:solidFill>
-                  <a:srgbClr val="FFFFFF"/>
+                  <a:srgbClr val="334155"/>
                 </a:solidFill>
                 <a:latin typeface="Segoe UI"/>
               </a:defRPr>
@@ -3660,7 +3660,7 @@
               </a:spcAft>
               <a:defRPr sz="1600">
                 <a:solidFill>
-                  <a:srgbClr val="FFFFFF"/>
+                  <a:srgbClr val="334155"/>
                 </a:solidFill>
                 <a:latin typeface="Segoe UI"/>
               </a:defRPr>
@@ -3685,7 +3685,7 @@
     <p:bg>
       <p:bgPr>
         <a:solidFill>
-          <a:srgbClr val="0F172A"/>
+          <a:srgbClr val="F8FAFC"/>
         </a:solidFill>
         <a:effectLst/>
       </p:bgPr>
@@ -3725,7 +3725,7 @@
               </a:spcAft>
               <a:defRPr sz="1200" b="1">
                 <a:solidFill>
-                  <a:srgbClr val="0EA5E9"/>
+                  <a:srgbClr val="2563EB"/>
                 </a:solidFill>
                 <a:latin typeface="Segoe UI"/>
               </a:defRPr>
@@ -3738,7 +3738,7 @@
             <a:pPr>
               <a:defRPr sz="3600" b="1">
                 <a:solidFill>
-                  <a:srgbClr val="FFFFFF"/>
+                  <a:srgbClr val="0F172A"/>
                 </a:solidFill>
                 <a:latin typeface="Segoe UI"/>
               </a:defRPr>
@@ -3751,7 +3751,7 @@
             <a:pPr>
               <a:defRPr sz="1600">
                 <a:solidFill>
-                  <a:srgbClr val="A855F7"/>
+                  <a:srgbClr val="64748B"/>
                 </a:solidFill>
                 <a:latin typeface="Segoe UI"/>
               </a:defRPr>
@@ -3793,7 +3793,7 @@
               </a:spcAft>
               <a:defRPr sz="1600">
                 <a:solidFill>
-                  <a:srgbClr val="FFFFFF"/>
+                  <a:srgbClr val="334155"/>
                 </a:solidFill>
                 <a:latin typeface="Segoe UI"/>
               </a:defRPr>
@@ -3812,7 +3812,7 @@
               </a:spcAft>
               <a:defRPr sz="1600">
                 <a:solidFill>
-                  <a:srgbClr val="FFFFFF"/>
+                  <a:srgbClr val="334155"/>
                 </a:solidFill>
                 <a:latin typeface="Segoe UI"/>
               </a:defRPr>
@@ -3831,7 +3831,7 @@
               </a:spcAft>
               <a:defRPr sz="1600">
                 <a:solidFill>
-                  <a:srgbClr val="FFFFFF"/>
+                  <a:srgbClr val="334155"/>
                 </a:solidFill>
                 <a:latin typeface="Segoe UI"/>
               </a:defRPr>
@@ -3850,7 +3850,7 @@
               </a:spcAft>
               <a:defRPr sz="1600">
                 <a:solidFill>
-                  <a:srgbClr val="FFFFFF"/>
+                  <a:srgbClr val="334155"/>
                 </a:solidFill>
                 <a:latin typeface="Segoe UI"/>
               </a:defRPr>
@@ -3869,7 +3869,7 @@
               </a:spcAft>
               <a:defRPr sz="1600">
                 <a:solidFill>
-                  <a:srgbClr val="FFFFFF"/>
+                  <a:srgbClr val="334155"/>
                 </a:solidFill>
                 <a:latin typeface="Segoe UI"/>
               </a:defRPr>
@@ -3894,7 +3894,7 @@
     <p:bg>
       <p:bgPr>
         <a:solidFill>
-          <a:srgbClr val="0F172A"/>
+          <a:srgbClr val="F8FAFC"/>
         </a:solidFill>
         <a:effectLst/>
       </p:bgPr>
@@ -3934,7 +3934,7 @@
               </a:spcAft>
               <a:defRPr sz="1200" b="1">
                 <a:solidFill>
-                  <a:srgbClr val="0EA5E9"/>
+                  <a:srgbClr val="2563EB"/>
                 </a:solidFill>
                 <a:latin typeface="Segoe UI"/>
               </a:defRPr>
@@ -3947,7 +3947,7 @@
             <a:pPr>
               <a:defRPr sz="3600" b="1">
                 <a:solidFill>
-                  <a:srgbClr val="FFFFFF"/>
+                  <a:srgbClr val="0F172A"/>
                 </a:solidFill>
                 <a:latin typeface="Segoe UI"/>
               </a:defRPr>
@@ -3960,7 +3960,7 @@
             <a:pPr>
               <a:defRPr sz="1600">
                 <a:solidFill>
-                  <a:srgbClr val="A855F7"/>
+                  <a:srgbClr val="64748B"/>
                 </a:solidFill>
                 <a:latin typeface="Segoe UI"/>
               </a:defRPr>
@@ -4002,7 +4002,7 @@
               </a:spcAft>
               <a:defRPr sz="1600">
                 <a:solidFill>
-                  <a:srgbClr val="FFFFFF"/>
+                  <a:srgbClr val="334155"/>
                 </a:solidFill>
                 <a:latin typeface="Segoe UI"/>
               </a:defRPr>
@@ -4021,7 +4021,7 @@
               </a:spcAft>
               <a:defRPr sz="1600">
                 <a:solidFill>
-                  <a:srgbClr val="FFFFFF"/>
+                  <a:srgbClr val="334155"/>
                 </a:solidFill>
                 <a:latin typeface="Segoe UI"/>
               </a:defRPr>
@@ -4040,7 +4040,7 @@
               </a:spcAft>
               <a:defRPr sz="1600">
                 <a:solidFill>
-                  <a:srgbClr val="FFFFFF"/>
+                  <a:srgbClr val="334155"/>
                 </a:solidFill>
                 <a:latin typeface="Segoe UI"/>
               </a:defRPr>
@@ -4059,7 +4059,7 @@
               </a:spcAft>
               <a:defRPr sz="1600">
                 <a:solidFill>
-                  <a:srgbClr val="FFFFFF"/>
+                  <a:srgbClr val="334155"/>
                 </a:solidFill>
                 <a:latin typeface="Segoe UI"/>
               </a:defRPr>
@@ -4078,7 +4078,7 @@
               </a:spcAft>
               <a:defRPr sz="1600">
                 <a:solidFill>
-                  <a:srgbClr val="FFFFFF"/>
+                  <a:srgbClr val="334155"/>
                 </a:solidFill>
                 <a:latin typeface="Segoe UI"/>
               </a:defRPr>
@@ -4103,7 +4103,7 @@
     <p:bg>
       <p:bgPr>
         <a:solidFill>
-          <a:srgbClr val="0F172A"/>
+          <a:srgbClr val="F8FAFC"/>
         </a:solidFill>
         <a:effectLst/>
       </p:bgPr>
@@ -4143,7 +4143,7 @@
               </a:spcAft>
               <a:defRPr sz="1200" b="1">
                 <a:solidFill>
-                  <a:srgbClr val="0EA5E9"/>
+                  <a:srgbClr val="2563EB"/>
                 </a:solidFill>
                 <a:latin typeface="Segoe UI"/>
               </a:defRPr>
@@ -4156,7 +4156,7 @@
             <a:pPr>
               <a:defRPr sz="3600" b="1">
                 <a:solidFill>
-                  <a:srgbClr val="FFFFFF"/>
+                  <a:srgbClr val="0F172A"/>
                 </a:solidFill>
                 <a:latin typeface="Segoe UI"/>
               </a:defRPr>
@@ -4169,7 +4169,7 @@
             <a:pPr>
               <a:defRPr sz="1600">
                 <a:solidFill>
-                  <a:srgbClr val="A855F7"/>
+                  <a:srgbClr val="64748B"/>
                 </a:solidFill>
                 <a:latin typeface="Segoe UI"/>
               </a:defRPr>
@@ -4211,7 +4211,7 @@
               </a:spcAft>
               <a:defRPr sz="1600">
                 <a:solidFill>
-                  <a:srgbClr val="FFFFFF"/>
+                  <a:srgbClr val="334155"/>
                 </a:solidFill>
                 <a:latin typeface="Segoe UI"/>
               </a:defRPr>
@@ -4230,7 +4230,7 @@
               </a:spcAft>
               <a:defRPr sz="1600">
                 <a:solidFill>
-                  <a:srgbClr val="FFFFFF"/>
+                  <a:srgbClr val="334155"/>
                 </a:solidFill>
                 <a:latin typeface="Segoe UI"/>
               </a:defRPr>
@@ -4249,7 +4249,7 @@
               </a:spcAft>
               <a:defRPr sz="1600">
                 <a:solidFill>
-                  <a:srgbClr val="FFFFFF"/>
+                  <a:srgbClr val="334155"/>
                 </a:solidFill>
                 <a:latin typeface="Segoe UI"/>
               </a:defRPr>
@@ -4268,7 +4268,7 @@
               </a:spcAft>
               <a:defRPr sz="1600">
                 <a:solidFill>
-                  <a:srgbClr val="FFFFFF"/>
+                  <a:srgbClr val="334155"/>
                 </a:solidFill>
                 <a:latin typeface="Segoe UI"/>
               </a:defRPr>
@@ -4287,7 +4287,7 @@
               </a:spcAft>
               <a:defRPr sz="1600">
                 <a:solidFill>
-                  <a:srgbClr val="FFFFFF"/>
+                  <a:srgbClr val="334155"/>
                 </a:solidFill>
                 <a:latin typeface="Segoe UI"/>
               </a:defRPr>
@@ -4312,7 +4312,7 @@
     <p:bg>
       <p:bgPr>
         <a:solidFill>
-          <a:srgbClr val="0F172A"/>
+          <a:srgbClr val="F8FAFC"/>
         </a:solidFill>
         <a:effectLst/>
       </p:bgPr>
@@ -4352,7 +4352,7 @@
               </a:spcAft>
               <a:defRPr sz="1200" b="1">
                 <a:solidFill>
-                  <a:srgbClr val="0EA5E9"/>
+                  <a:srgbClr val="2563EB"/>
                 </a:solidFill>
                 <a:latin typeface="Segoe UI"/>
               </a:defRPr>
@@ -4365,7 +4365,7 @@
             <a:pPr>
               <a:defRPr sz="3600" b="1">
                 <a:solidFill>
-                  <a:srgbClr val="FFFFFF"/>
+                  <a:srgbClr val="0F172A"/>
                 </a:solidFill>
                 <a:latin typeface="Segoe UI"/>
               </a:defRPr>
@@ -4378,7 +4378,7 @@
             <a:pPr>
               <a:defRPr sz="1600">
                 <a:solidFill>
-                  <a:srgbClr val="A855F7"/>
+                  <a:srgbClr val="64748B"/>
                 </a:solidFill>
                 <a:latin typeface="Segoe UI"/>
               </a:defRPr>
@@ -4420,7 +4420,7 @@
               </a:spcAft>
               <a:defRPr sz="1600">
                 <a:solidFill>
-                  <a:srgbClr val="FFFFFF"/>
+                  <a:srgbClr val="334155"/>
                 </a:solidFill>
                 <a:latin typeface="Segoe UI"/>
               </a:defRPr>
@@ -4439,7 +4439,7 @@
               </a:spcAft>
               <a:defRPr sz="1600">
                 <a:solidFill>
-                  <a:srgbClr val="FFFFFF"/>
+                  <a:srgbClr val="334155"/>
                 </a:solidFill>
                 <a:latin typeface="Segoe UI"/>
               </a:defRPr>
@@ -4458,7 +4458,7 @@
               </a:spcAft>
               <a:defRPr sz="1600">
                 <a:solidFill>
-                  <a:srgbClr val="FFFFFF"/>
+                  <a:srgbClr val="334155"/>
                 </a:solidFill>
                 <a:latin typeface="Segoe UI"/>
               </a:defRPr>
@@ -4477,7 +4477,7 @@
               </a:spcAft>
               <a:defRPr sz="1600">
                 <a:solidFill>
-                  <a:srgbClr val="FFFFFF"/>
+                  <a:srgbClr val="334155"/>
                 </a:solidFill>
                 <a:latin typeface="Segoe UI"/>
               </a:defRPr>
@@ -4496,7 +4496,7 @@
               </a:spcAft>
               <a:defRPr sz="1600">
                 <a:solidFill>
-                  <a:srgbClr val="FFFFFF"/>
+                  <a:srgbClr val="334155"/>
                 </a:solidFill>
                 <a:latin typeface="Segoe UI"/>
               </a:defRPr>
@@ -4521,7 +4521,7 @@
     <p:bg>
       <p:bgPr>
         <a:solidFill>
-          <a:srgbClr val="0F172A"/>
+          <a:srgbClr val="F8FAFC"/>
         </a:solidFill>
         <a:effectLst/>
       </p:bgPr>
@@ -4561,7 +4561,7 @@
               </a:spcAft>
               <a:defRPr sz="1200" b="1">
                 <a:solidFill>
-                  <a:srgbClr val="0EA5E9"/>
+                  <a:srgbClr val="2563EB"/>
                 </a:solidFill>
                 <a:latin typeface="Segoe UI"/>
               </a:defRPr>
@@ -4574,7 +4574,7 @@
             <a:pPr>
               <a:defRPr sz="3600" b="1">
                 <a:solidFill>
-                  <a:srgbClr val="FFFFFF"/>
+                  <a:srgbClr val="0F172A"/>
                 </a:solidFill>
                 <a:latin typeface="Segoe UI"/>
               </a:defRPr>
@@ -4587,7 +4587,7 @@
             <a:pPr>
               <a:defRPr sz="1600">
                 <a:solidFill>
-                  <a:srgbClr val="A855F7"/>
+                  <a:srgbClr val="64748B"/>
                 </a:solidFill>
                 <a:latin typeface="Segoe UI"/>
               </a:defRPr>
@@ -4629,7 +4629,7 @@
               </a:spcAft>
               <a:defRPr sz="1600">
                 <a:solidFill>
-                  <a:srgbClr val="FFFFFF"/>
+                  <a:srgbClr val="334155"/>
                 </a:solidFill>
                 <a:latin typeface="Segoe UI"/>
               </a:defRPr>
@@ -4648,7 +4648,7 @@
               </a:spcAft>
               <a:defRPr sz="1600">
                 <a:solidFill>
-                  <a:srgbClr val="FFFFFF"/>
+                  <a:srgbClr val="334155"/>
                 </a:solidFill>
                 <a:latin typeface="Segoe UI"/>
               </a:defRPr>
@@ -4667,7 +4667,7 @@
               </a:spcAft>
               <a:defRPr sz="1600">
                 <a:solidFill>
-                  <a:srgbClr val="FFFFFF"/>
+                  <a:srgbClr val="334155"/>
                 </a:solidFill>
                 <a:latin typeface="Segoe UI"/>
               </a:defRPr>
@@ -4686,7 +4686,7 @@
               </a:spcAft>
               <a:defRPr sz="1600">
                 <a:solidFill>
-                  <a:srgbClr val="FFFFFF"/>
+                  <a:srgbClr val="334155"/>
                 </a:solidFill>
                 <a:latin typeface="Segoe UI"/>
               </a:defRPr>
@@ -4705,7 +4705,7 @@
               </a:spcAft>
               <a:defRPr sz="1600">
                 <a:solidFill>
-                  <a:srgbClr val="FFFFFF"/>
+                  <a:srgbClr val="334155"/>
                 </a:solidFill>
                 <a:latin typeface="Segoe UI"/>
               </a:defRPr>
@@ -4730,7 +4730,7 @@
     <p:bg>
       <p:bgPr>
         <a:solidFill>
-          <a:srgbClr val="0F172A"/>
+          <a:srgbClr val="F8FAFC"/>
         </a:solidFill>
         <a:effectLst/>
       </p:bgPr>
@@ -4770,7 +4770,7 @@
               </a:spcAft>
               <a:defRPr sz="1200" b="1">
                 <a:solidFill>
-                  <a:srgbClr val="0EA5E9"/>
+                  <a:srgbClr val="2563EB"/>
                 </a:solidFill>
                 <a:latin typeface="Segoe UI"/>
               </a:defRPr>
@@ -4783,7 +4783,7 @@
             <a:pPr>
               <a:defRPr sz="3600" b="1">
                 <a:solidFill>
-                  <a:srgbClr val="FFFFFF"/>
+                  <a:srgbClr val="0F172A"/>
                 </a:solidFill>
                 <a:latin typeface="Segoe UI"/>
               </a:defRPr>
@@ -4796,7 +4796,7 @@
             <a:pPr>
               <a:defRPr sz="1600">
                 <a:solidFill>
-                  <a:srgbClr val="A855F7"/>
+                  <a:srgbClr val="64748B"/>
                 </a:solidFill>
                 <a:latin typeface="Segoe UI"/>
               </a:defRPr>
@@ -4838,7 +4838,7 @@
               </a:spcAft>
               <a:defRPr sz="1600">
                 <a:solidFill>
-                  <a:srgbClr val="FFFFFF"/>
+                  <a:srgbClr val="334155"/>
                 </a:solidFill>
                 <a:latin typeface="Segoe UI"/>
               </a:defRPr>
@@ -4857,7 +4857,7 @@
               </a:spcAft>
               <a:defRPr sz="1600">
                 <a:solidFill>
-                  <a:srgbClr val="FFFFFF"/>
+                  <a:srgbClr val="334155"/>
                 </a:solidFill>
                 <a:latin typeface="Segoe UI"/>
               </a:defRPr>
@@ -4876,7 +4876,7 @@
               </a:spcAft>
               <a:defRPr sz="1600">
                 <a:solidFill>
-                  <a:srgbClr val="FFFFFF"/>
+                  <a:srgbClr val="334155"/>
                 </a:solidFill>
                 <a:latin typeface="Segoe UI"/>
               </a:defRPr>
@@ -4895,7 +4895,7 @@
               </a:spcAft>
               <a:defRPr sz="1600">
                 <a:solidFill>
-                  <a:srgbClr val="FFFFFF"/>
+                  <a:srgbClr val="334155"/>
                 </a:solidFill>
                 <a:latin typeface="Segoe UI"/>
               </a:defRPr>
@@ -4914,7 +4914,7 @@
               </a:spcAft>
               <a:defRPr sz="1600">
                 <a:solidFill>
-                  <a:srgbClr val="FFFFFF"/>
+                  <a:srgbClr val="334155"/>
                 </a:solidFill>
                 <a:latin typeface="Segoe UI"/>
               </a:defRPr>
@@ -4939,7 +4939,7 @@
     <p:bg>
       <p:bgPr>
         <a:solidFill>
-          <a:srgbClr val="0F172A"/>
+          <a:srgbClr val="F8FAFC"/>
         </a:solidFill>
         <a:effectLst/>
       </p:bgPr>
@@ -4979,7 +4979,7 @@
               </a:spcAft>
               <a:defRPr sz="1200" b="1">
                 <a:solidFill>
-                  <a:srgbClr val="0EA5E9"/>
+                  <a:srgbClr val="2563EB"/>
                 </a:solidFill>
                 <a:latin typeface="Segoe UI"/>
               </a:defRPr>
@@ -4992,7 +4992,7 @@
             <a:pPr>
               <a:defRPr sz="3600" b="1">
                 <a:solidFill>
-                  <a:srgbClr val="FFFFFF"/>
+                  <a:srgbClr val="0F172A"/>
                 </a:solidFill>
                 <a:latin typeface="Segoe UI"/>
               </a:defRPr>
@@ -5005,7 +5005,7 @@
             <a:pPr>
               <a:defRPr sz="1600">
                 <a:solidFill>
-                  <a:srgbClr val="A855F7"/>
+                  <a:srgbClr val="64748B"/>
                 </a:solidFill>
                 <a:latin typeface="Segoe UI"/>
               </a:defRPr>
@@ -5047,7 +5047,7 @@
               </a:spcAft>
               <a:defRPr sz="1600">
                 <a:solidFill>
-                  <a:srgbClr val="FFFFFF"/>
+                  <a:srgbClr val="334155"/>
                 </a:solidFill>
                 <a:latin typeface="Segoe UI"/>
               </a:defRPr>
@@ -5066,7 +5066,7 @@
               </a:spcAft>
               <a:defRPr sz="1600">
                 <a:solidFill>
-                  <a:srgbClr val="FFFFFF"/>
+                  <a:srgbClr val="334155"/>
                 </a:solidFill>
                 <a:latin typeface="Segoe UI"/>
               </a:defRPr>
@@ -5085,7 +5085,7 @@
               </a:spcAft>
               <a:defRPr sz="1600">
                 <a:solidFill>
-                  <a:srgbClr val="FFFFFF"/>
+                  <a:srgbClr val="334155"/>
                 </a:solidFill>
                 <a:latin typeface="Segoe UI"/>
               </a:defRPr>
@@ -5104,7 +5104,7 @@
               </a:spcAft>
               <a:defRPr sz="1600">
                 <a:solidFill>
-                  <a:srgbClr val="FFFFFF"/>
+                  <a:srgbClr val="334155"/>
                 </a:solidFill>
                 <a:latin typeface="Segoe UI"/>
               </a:defRPr>
@@ -5123,7 +5123,7 @@
               </a:spcAft>
               <a:defRPr sz="1600">
                 <a:solidFill>
-                  <a:srgbClr val="FFFFFF"/>
+                  <a:srgbClr val="334155"/>
                 </a:solidFill>
                 <a:latin typeface="Segoe UI"/>
               </a:defRPr>

</xml_diff>